<commit_message>
data configuration on going
</commit_message>
<xml_diff>
--- a/Presentation1.pptx
+++ b/Presentation1.pptx
@@ -206,7 +206,7 @@
           <a:p>
             <a:fld id="{270D664D-AE16-419C-833B-9C72519B3CEF}" type="datetimeFigureOut">
               <a:rPr lang="en-IN" smtClean="0"/>
-              <a:t>16-09-2026</a:t>
+              <a:t>17-09-2026</a:t>
             </a:fld>
             <a:endParaRPr lang="en-IN"/>
           </a:p>
@@ -707,7 +707,7 @@
           <a:p>
             <a:fld id="{BBE9735F-C216-446E-A09D-3BEA34043A55}" type="datetimeFigureOut">
               <a:rPr lang="en-IN" smtClean="0"/>
-              <a:t>16-09-2026</a:t>
+              <a:t>17-09-2026</a:t>
             </a:fld>
             <a:endParaRPr lang="en-IN"/>
           </a:p>
@@ -907,7 +907,7 @@
           <a:p>
             <a:fld id="{BBE9735F-C216-446E-A09D-3BEA34043A55}" type="datetimeFigureOut">
               <a:rPr lang="en-IN" smtClean="0"/>
-              <a:t>16-09-2026</a:t>
+              <a:t>17-09-2026</a:t>
             </a:fld>
             <a:endParaRPr lang="en-IN"/>
           </a:p>
@@ -1117,7 +1117,7 @@
           <a:p>
             <a:fld id="{BBE9735F-C216-446E-A09D-3BEA34043A55}" type="datetimeFigureOut">
               <a:rPr lang="en-IN" smtClean="0"/>
-              <a:t>16-09-2026</a:t>
+              <a:t>17-09-2026</a:t>
             </a:fld>
             <a:endParaRPr lang="en-IN"/>
           </a:p>
@@ -1317,7 +1317,7 @@
           <a:p>
             <a:fld id="{BBE9735F-C216-446E-A09D-3BEA34043A55}" type="datetimeFigureOut">
               <a:rPr lang="en-IN" smtClean="0"/>
-              <a:t>16-09-2026</a:t>
+              <a:t>17-09-2026</a:t>
             </a:fld>
             <a:endParaRPr lang="en-IN"/>
           </a:p>
@@ -1593,7 +1593,7 @@
           <a:p>
             <a:fld id="{BBE9735F-C216-446E-A09D-3BEA34043A55}" type="datetimeFigureOut">
               <a:rPr lang="en-IN" smtClean="0"/>
-              <a:t>16-09-2026</a:t>
+              <a:t>17-09-2026</a:t>
             </a:fld>
             <a:endParaRPr lang="en-IN"/>
           </a:p>
@@ -1861,7 +1861,7 @@
           <a:p>
             <a:fld id="{BBE9735F-C216-446E-A09D-3BEA34043A55}" type="datetimeFigureOut">
               <a:rPr lang="en-IN" smtClean="0"/>
-              <a:t>16-09-2026</a:t>
+              <a:t>17-09-2026</a:t>
             </a:fld>
             <a:endParaRPr lang="en-IN"/>
           </a:p>
@@ -2276,7 +2276,7 @@
           <a:p>
             <a:fld id="{BBE9735F-C216-446E-A09D-3BEA34043A55}" type="datetimeFigureOut">
               <a:rPr lang="en-IN" smtClean="0"/>
-              <a:t>16-09-2026</a:t>
+              <a:t>17-09-2026</a:t>
             </a:fld>
             <a:endParaRPr lang="en-IN"/>
           </a:p>
@@ -2418,7 +2418,7 @@
           <a:p>
             <a:fld id="{BBE9735F-C216-446E-A09D-3BEA34043A55}" type="datetimeFigureOut">
               <a:rPr lang="en-IN" smtClean="0"/>
-              <a:t>16-09-2026</a:t>
+              <a:t>17-09-2026</a:t>
             </a:fld>
             <a:endParaRPr lang="en-IN"/>
           </a:p>
@@ -2531,7 +2531,7 @@
           <a:p>
             <a:fld id="{BBE9735F-C216-446E-A09D-3BEA34043A55}" type="datetimeFigureOut">
               <a:rPr lang="en-IN" smtClean="0"/>
-              <a:t>16-09-2026</a:t>
+              <a:t>17-09-2026</a:t>
             </a:fld>
             <a:endParaRPr lang="en-IN"/>
           </a:p>
@@ -2844,7 +2844,7 @@
           <a:p>
             <a:fld id="{BBE9735F-C216-446E-A09D-3BEA34043A55}" type="datetimeFigureOut">
               <a:rPr lang="en-IN" smtClean="0"/>
-              <a:t>16-09-2026</a:t>
+              <a:t>17-09-2026</a:t>
             </a:fld>
             <a:endParaRPr lang="en-IN"/>
           </a:p>
@@ -3133,7 +3133,7 @@
           <a:p>
             <a:fld id="{BBE9735F-C216-446E-A09D-3BEA34043A55}" type="datetimeFigureOut">
               <a:rPr lang="en-IN" smtClean="0"/>
-              <a:t>16-09-2026</a:t>
+              <a:t>17-09-2026</a:t>
             </a:fld>
             <a:endParaRPr lang="en-IN"/>
           </a:p>
@@ -3376,7 +3376,7 @@
           <a:p>
             <a:fld id="{BBE9735F-C216-446E-A09D-3BEA34043A55}" type="datetimeFigureOut">
               <a:rPr lang="en-IN" smtClean="0"/>
-              <a:t>16-09-2026</a:t>
+              <a:t>17-09-2026</a:t>
             </a:fld>
             <a:endParaRPr lang="en-IN"/>
           </a:p>
@@ -3860,7 +3860,7 @@
         <p:spPr>
           <a:xfrm>
             <a:off x="160420" y="657085"/>
-            <a:ext cx="7346804" cy="1077218"/>
+            <a:ext cx="11140402" cy="1077218"/>
           </a:xfrm>
           <a:prstGeom prst="rect">
             <a:avLst/>
@@ -3879,7 +3879,7 @@
                   <a:srgbClr val="000435"/>
                 </a:solidFill>
               </a:rPr>
-              <a:t>Cloud Removal from LISS-IV Satellite Imagery</a:t>
+              <a:t>Generative AI-Based Cloud Removal &amp; Reconstruction for LISS-IV Satellite Imagery</a:t>
             </a:r>
           </a:p>
         </p:txBody>
@@ -4539,7 +4539,7 @@
         <p:spPr>
           <a:xfrm>
             <a:off x="385011" y="1106905"/>
-            <a:ext cx="11389894" cy="4031873"/>
+            <a:ext cx="11389894" cy="4247317"/>
           </a:xfrm>
           <a:prstGeom prst="rect">
             <a:avLst/>
@@ -4552,137 +4552,143 @@
           </a:bodyPr>
           <a:lstStyle/>
           <a:p>
+            <a:r>
+              <a:rPr lang="en-IN" b="1" dirty="0"/>
+              <a:t>[1]</a:t>
+            </a:r>
+            <a:r>
+              <a:rPr lang="en-IN" dirty="0"/>
+              <a:t> </a:t>
+            </a:r>
+            <a:r>
+              <a:rPr lang="en-IN" i="1" dirty="0"/>
+              <a:t>Cloud Removal Advances: A Comprehensive Review and Analysis for Optical Remote Sensing Images.</a:t>
+            </a:r>
+          </a:p>
+          <a:p>
             <a:endParaRPr lang="en-IN" dirty="0"/>
           </a:p>
           <a:p>
             <a:r>
-              <a:rPr lang="en-IN" sz="2000" b="1" dirty="0"/>
-              <a:t>[1]</a:t>
-            </a:r>
-            <a:r>
-              <a:rPr lang="en-IN" sz="2000" dirty="0"/>
+              <a:rPr lang="en-IN" b="1" dirty="0"/>
+              <a:t>[2]</a:t>
+            </a:r>
+            <a:r>
+              <a:rPr lang="en-IN" dirty="0"/>
               <a:t> </a:t>
             </a:r>
             <a:r>
-              <a:rPr lang="en-IN" sz="2000" dirty="0" err="1"/>
+              <a:rPr lang="en-IN" dirty="0" err="1"/>
               <a:t>Meraner</a:t>
             </a:r>
             <a:r>
-              <a:rPr lang="en-IN" sz="2000" dirty="0"/>
+              <a:rPr lang="en-IN" dirty="0"/>
               <a:t>, A., Ebel, P., Schmitt, M., &amp; Zhu, X. X. (2020). </a:t>
             </a:r>
             <a:r>
-              <a:rPr lang="en-IN" sz="2000" i="1" dirty="0"/>
+              <a:rPr lang="en-IN" i="1" dirty="0"/>
               <a:t>Cloud removal in Sentinel-2 imagery using a deep residual neural network and SAR-optical data fusion.</a:t>
             </a:r>
             <a:r>
-              <a:rPr lang="en-IN" sz="2000" dirty="0"/>
+              <a:rPr lang="en-IN" dirty="0"/>
               <a:t> ISPRS Journal of Photogrammetry and Remote Sensing.</a:t>
             </a:r>
           </a:p>
           <a:p>
-            <a:r>
-              <a:rPr lang="en-IN" sz="2000" b="1" dirty="0"/>
-              <a:t>[2]</a:t>
-            </a:r>
-            <a:r>
-              <a:rPr lang="en-IN" sz="2000" dirty="0"/>
+            <a:endParaRPr lang="en-IN" dirty="0"/>
+          </a:p>
+          <a:p>
+            <a:r>
+              <a:rPr lang="en-IN" b="1" dirty="0"/>
+              <a:t>[3]</a:t>
+            </a:r>
+            <a:r>
+              <a:rPr lang="en-IN" dirty="0"/>
               <a:t> Li, Y., et al. (2020). </a:t>
             </a:r>
             <a:r>
-              <a:rPr lang="en-IN" sz="2000" i="1" dirty="0"/>
+              <a:rPr lang="en-IN" i="1" dirty="0"/>
               <a:t>Thin cloud removal in optical remote sensing images based on generative adversarial networks and physical model of cloud distortion.</a:t>
             </a:r>
-            <a:endParaRPr lang="en-IN" sz="2000" dirty="0"/>
-          </a:p>
-          <a:p>
-            <a:r>
-              <a:rPr lang="en-IN" sz="2000" b="1" dirty="0"/>
-              <a:t>[3]</a:t>
-            </a:r>
-            <a:r>
-              <a:rPr lang="en-IN" sz="2000" dirty="0"/>
+          </a:p>
+          <a:p>
+            <a:endParaRPr lang="en-IN" dirty="0"/>
+          </a:p>
+          <a:p>
+            <a:r>
+              <a:rPr lang="en-IN" b="1" dirty="0"/>
+              <a:t>[4]</a:t>
+            </a:r>
+            <a:r>
+              <a:rPr lang="en-IN" dirty="0"/>
               <a:t> Zhou, X., et al. (2024). </a:t>
             </a:r>
             <a:r>
-              <a:rPr lang="en-IN" sz="2000" i="1" dirty="0" err="1"/>
+              <a:rPr lang="en-IN" i="1" dirty="0" err="1"/>
               <a:t>AllClear</a:t>
             </a:r>
             <a:r>
-              <a:rPr lang="en-IN" sz="2000" i="1" dirty="0"/>
+              <a:rPr lang="en-IN" i="1" dirty="0"/>
               <a:t>: A Comprehensive Dataset and Benchmark for Cloud Removal in Satellite Imagery.</a:t>
             </a:r>
             <a:r>
-              <a:rPr lang="en-IN" sz="2000" dirty="0"/>
+              <a:rPr lang="en-IN" dirty="0"/>
               <a:t> </a:t>
             </a:r>
             <a:r>
-              <a:rPr lang="en-IN" sz="2000" dirty="0" err="1"/>
+              <a:rPr lang="en-IN" dirty="0" err="1"/>
               <a:t>NeurIPS</a:t>
             </a:r>
             <a:r>
-              <a:rPr lang="en-IN" sz="2000" dirty="0"/>
+              <a:rPr lang="en-IN" dirty="0"/>
               <a:t> 2024.</a:t>
             </a:r>
           </a:p>
           <a:p>
-            <a:r>
-              <a:rPr lang="en-IN" sz="2000" b="1" dirty="0"/>
-              <a:t>[4]</a:t>
-            </a:r>
-            <a:r>
-              <a:rPr lang="en-IN" sz="2000" dirty="0"/>
+            <a:endParaRPr lang="en-IN" dirty="0"/>
+          </a:p>
+          <a:p>
+            <a:r>
+              <a:rPr lang="en-IN" b="1" dirty="0"/>
+              <a:t>[5]</a:t>
+            </a:r>
+            <a:r>
+              <a:rPr lang="en-IN" dirty="0"/>
+              <a:t> ESA. </a:t>
+            </a:r>
+            <a:r>
+              <a:rPr lang="en-IN" i="1" dirty="0"/>
+              <a:t>Copernicus Sentinel-2 Mission and Multispectral Instrument documentation.</a:t>
+            </a:r>
+          </a:p>
+          <a:p>
+            <a:endParaRPr lang="en-IN" dirty="0"/>
+          </a:p>
+          <a:p>
+            <a:r>
+              <a:rPr lang="en-IN" b="1" dirty="0"/>
+              <a:t>[6]</a:t>
+            </a:r>
+            <a:r>
+              <a:rPr lang="en-IN" dirty="0"/>
               <a:t> </a:t>
             </a:r>
             <a:r>
-              <a:rPr lang="en-IN" sz="2000" dirty="0" err="1"/>
+              <a:rPr lang="en-IN" dirty="0" err="1"/>
               <a:t>Ronneberger</a:t>
             </a:r>
             <a:r>
-              <a:rPr lang="en-IN" sz="2000" dirty="0"/>
+              <a:rPr lang="en-IN" dirty="0"/>
               <a:t>, O., Fischer, P., &amp; Brox, T. (2015). </a:t>
             </a:r>
             <a:r>
-              <a:rPr lang="en-IN" sz="2000" i="1" dirty="0"/>
+              <a:rPr lang="en-IN" i="1" dirty="0"/>
               <a:t>U-Net: Convolutional Networks for Biomedical Image Segmentation.</a:t>
             </a:r>
             <a:r>
-              <a:rPr lang="en-IN" sz="2000" dirty="0"/>
+              <a:rPr lang="en-IN" dirty="0"/>
               <a:t> MICCAI.</a:t>
             </a:r>
-          </a:p>
-          <a:p>
-            <a:r>
-              <a:rPr lang="en-IN" sz="2000" b="1" dirty="0"/>
-              <a:t>[5]</a:t>
-            </a:r>
-            <a:r>
-              <a:rPr lang="en-IN" sz="2000" dirty="0"/>
-              <a:t> ISRO. </a:t>
-            </a:r>
-            <a:r>
-              <a:rPr lang="en-IN" sz="2000" i="1" dirty="0"/>
-              <a:t>Resourcesat-2/2A and LISS-IV sensor/product documentation.</a:t>
-            </a:r>
-            <a:endParaRPr lang="en-IN" sz="2000" dirty="0"/>
-          </a:p>
-          <a:p>
-            <a:r>
-              <a:rPr lang="en-IN" sz="2000" b="1" dirty="0"/>
-              <a:t>[6]</a:t>
-            </a:r>
-            <a:r>
-              <a:rPr lang="en-IN" sz="2000" dirty="0"/>
-              <a:t> ESA. </a:t>
-            </a:r>
-            <a:r>
-              <a:rPr lang="en-IN" sz="2000" i="1" dirty="0"/>
-              <a:t>Copernicus Sentinel-2 Mission and Multispectral Instrument documentation.</a:t>
-            </a:r>
-            <a:endParaRPr lang="en-IN" sz="2000" dirty="0"/>
-          </a:p>
-          <a:p>
-            <a:endParaRPr lang="en-IN" dirty="0"/>
           </a:p>
         </p:txBody>
       </p:sp>
@@ -8564,10 +8570,10 @@
       </p:sp>
       <p:pic>
         <p:nvPicPr>
-          <p:cNvPr id="9" name="Picture 8">
-            <a:extLst>
-              <a:ext uri="{FF2B5EF4-FFF2-40B4-BE49-F238E27FC236}">
-                <a16:creationId xmlns:a16="http://schemas.microsoft.com/office/drawing/2014/main" id="{409BE380-7DA9-80C2-C389-7BA3DECDD9F1}"/>
+          <p:cNvPr id="5" name="Picture 4" descr="IIITN Logo">
+            <a:extLst>
+              <a:ext uri="{FF2B5EF4-FFF2-40B4-BE49-F238E27FC236}">
+                <a16:creationId xmlns:a16="http://schemas.microsoft.com/office/drawing/2014/main" id="{E1B76B65-D6AA-C925-0B19-3B28FF8E1F78}"/>
               </a:ext>
             </a:extLst>
           </p:cNvPr>
@@ -8577,21 +8583,15 @@
           <p:nvPr/>
         </p:nvPicPr>
         <p:blipFill>
-          <a:blip r:embed="rId2">
-            <a:extLst>
-              <a:ext uri="{28A0092B-C50C-407E-A947-70E740481C1C}">
-                <a14:useLocalDpi xmlns:a14="http://schemas.microsoft.com/office/drawing/2010/main" val="0"/>
-              </a:ext>
-            </a:extLst>
-          </a:blip>
+          <a:blip r:embed="rId2"/>
           <a:stretch>
             <a:fillRect/>
           </a:stretch>
         </p:blipFill>
         <p:spPr>
           <a:xfrm>
-            <a:off x="213157" y="854257"/>
-            <a:ext cx="7252920" cy="3626460"/>
+            <a:off x="11300822" y="183667"/>
+            <a:ext cx="730758" cy="730758"/>
           </a:xfrm>
           <a:prstGeom prst="rect">
             <a:avLst/>
@@ -8600,10 +8600,10 @@
       </p:pic>
       <p:pic>
         <p:nvPicPr>
-          <p:cNvPr id="5" name="Picture 4" descr="IIITN Logo">
-            <a:extLst>
-              <a:ext uri="{FF2B5EF4-FFF2-40B4-BE49-F238E27FC236}">
-                <a16:creationId xmlns:a16="http://schemas.microsoft.com/office/drawing/2014/main" id="{E1B76B65-D6AA-C925-0B19-3B28FF8E1F78}"/>
+          <p:cNvPr id="8" name="Picture 7">
+            <a:extLst>
+              <a:ext uri="{FF2B5EF4-FFF2-40B4-BE49-F238E27FC236}">
+                <a16:creationId xmlns:a16="http://schemas.microsoft.com/office/drawing/2014/main" id="{35B0D720-E512-DD37-928D-0BB192F9092A}"/>
               </a:ext>
             </a:extLst>
           </p:cNvPr>
@@ -8613,15 +8613,21 @@
           <p:nvPr/>
         </p:nvPicPr>
         <p:blipFill>
-          <a:blip r:embed="rId3"/>
+          <a:blip r:embed="rId3">
+            <a:extLst>
+              <a:ext uri="{28A0092B-C50C-407E-A947-70E740481C1C}">
+                <a14:useLocalDpi xmlns:a14="http://schemas.microsoft.com/office/drawing/2010/main" val="0"/>
+              </a:ext>
+            </a:extLst>
+          </a:blip>
           <a:stretch>
             <a:fillRect/>
           </a:stretch>
         </p:blipFill>
         <p:spPr>
           <a:xfrm>
-            <a:off x="11300822" y="183667"/>
-            <a:ext cx="730758" cy="730758"/>
+            <a:off x="265176" y="914425"/>
+            <a:ext cx="6893948" cy="3446974"/>
           </a:xfrm>
           <a:prstGeom prst="rect">
             <a:avLst/>
@@ -10027,7 +10033,7 @@
                   <a:srgbClr val="12304A"/>
                 </a:solidFill>
               </a:rPr>
-              <a:t>Evaluation Metrices</a:t>
+              <a:t>Evaluation Metrics</a:t>
             </a:r>
           </a:p>
         </p:txBody>

</xml_diff>